<commit_message>
Deepen Weeks 2 & 3 into full lectures + speaker notes
Following the Week 1 template:
- W2 (SDLC/Tooling/Fuzzing): add a "what each tool catches" worked example (SAST vs
  secret-scan vs DAST on a flawed endpoint) + per-slide speaker notes.
- W3 (Cryptography): add "why ECB leaks" (block-mapping) and "how hash cracking works"
  worked examples + per-slide speaker notes.
- Rebuilt week02.pptx / week03.pptx (15 speaker-note parts each); worked-example slides
  QA'd — code/diagram + bullets, no overflow.

Co-Authored-By: Claude Opus 4.8 <noreply@anthropic.com>
</commit_message>
<xml_diff>
--- a/slides/pptx/week02.pptx
+++ b/slides/pptx/week02.pptx
@@ -516,7 +516,7 @@
           <a:p>
             <a:r>
               <a:rPr lang="en-US" dirty="0"/>
-              <a:t/>
+              <a:t>Hook: open by running a scanner live on a flawed repo and let a finding pop up in seconds — "this is how the industry finds bugs at scale." Today = the tools + the mindset of catching bugs early. ~2 min.</a:t>
             </a:r>
             <a:endParaRPr lang="en-US" dirty="0"/>
           </a:p>
@@ -604,7 +604,7 @@
           <a:p>
             <a:r>
               <a:rPr lang="en-US" dirty="0"/>
-              <a:t/>
+              <a:t>Name the real tools they'll see in industry/internships. SonarQube = quality gate; GHAS = security native in GitHub. Connect "technical debt" to the cost curve from the recap. ~3 min.</a:t>
             </a:r>
             <a:endParaRPr lang="en-US" dirty="0"/>
           </a:p>
@@ -692,7 +692,7 @@
           <a:p>
             <a:r>
               <a:rPr lang="en-US" dirty="0"/>
-              <a:t/>
+              <a:t>Explain the game before lab: speed + accuracy. Penalize wild guessing (misclassified subtracts) so they must justify each finding. Mirrors a real bug-bounty triage queue. ~3 min.</a:t>
             </a:r>
             <a:endParaRPr lang="en-US" dirty="0"/>
           </a:p>
@@ -780,7 +780,7 @@
           <a:p>
             <a:r>
               <a:rPr lang="en-US" dirty="0"/>
-              <a:t/>
+              <a:t>Quick, fun, instant feedback (it crashes or it doesn't). Sets up W11. If short on time, make this a demo. ~2 min.</a:t>
             </a:r>
             <a:endParaRPr lang="en-US" dirty="0"/>
           </a:p>
@@ -868,7 +868,7 @@
           <a:p>
             <a:r>
               <a:rPr lang="en-US" dirty="0"/>
-              <a:t/>
+              <a:t>The graded output. Remind them to also scan the NoteVault project target (worksheet task) and to do the AI-resilient tasks. Point to scan.sh.</a:t>
             </a:r>
             <a:endParaRPr lang="en-US" dirty="0"/>
           </a:p>
@@ -956,7 +956,7 @@
           <a:p>
             <a:r>
               <a:rPr lang="en-US" dirty="0"/>
-              <a:t/>
+              <a:t>Recap, 3 lines. Cold-call: "name a bug SAST would miss but DAST would catch." ~2 min.</a:t>
             </a:r>
             <a:endParaRPr lang="en-US" dirty="0"/>
           </a:p>
@@ -1044,7 +1044,7 @@
           <a:p>
             <a:r>
               <a:rPr lang="en-US" dirty="0"/>
-              <a:t/>
+              <a:t>Cliffhanger: "Next week we break crypto — crack passwords and decrypt a secret in minutes." Remind: scanners ready in their VM.</a:t>
             </a:r>
             <a:endParaRPr lang="en-US" dirty="0"/>
           </a:p>
@@ -1132,7 +1132,7 @@
           <a:p>
             <a:r>
               <a:rPr lang="en-US" dirty="0"/>
-              <a:t/>
+              <a:t>Roadmap, 1 min. Flag the lab: scan a deliberately flawed repo, triage by CWE, then fix. Bonus: first team to crash a target with a fuzzer.</a:t>
             </a:r>
             <a:endParaRPr lang="en-US" dirty="0"/>
           </a:p>
@@ -1220,7 +1220,7 @@
           <a:p>
             <a:r>
               <a:rPr lang="en-US" dirty="0"/>
-              <a:t/>
+              <a:t>Bridge from W1. W1 = think (design). W2 = automate (code). Remind the cost curve: a bug caught in CI costs ~1×, in production ~100×. ~2 min.</a:t>
             </a:r>
             <a:endParaRPr lang="en-US" dirty="0"/>
           </a:p>
@@ -1308,7 +1308,7 @@
           <a:p>
             <a:r>
               <a:rPr lang="en-US" dirty="0"/>
-              <a:t/>
+              <a:t>Walk the phases on the board; ask "where can security live?" (answer: every phase). Threat modeling = design; SAST/secret scan = code/commit; DAST = test; monitoring = operate. "Shift left" = move detection earlier. ~5 min.</a:t>
             </a:r>
             <a:endParaRPr lang="en-US" dirty="0"/>
           </a:p>
@@ -1396,7 +1396,7 @@
           <a:p>
             <a:r>
               <a:rPr lang="en-US" dirty="0"/>
-              <a:t/>
+              <a:t>The mental map for the whole unit. Stress: no single tool finds everything — they see different things. Tie each to a later week (SCA → W12, DAST → Burp in W4-6). ~5 min.</a:t>
             </a:r>
             <a:endParaRPr lang="en-US" dirty="0"/>
           </a:p>
@@ -1484,7 +1484,7 @@
           <a:p>
             <a:r>
               <a:rPr lang="en-US" dirty="0"/>
-              <a:t/>
+              <a:t>The classic comparison students confuse. Analogy: SAST = proofreading the recipe; DAST = tasting the cooked dish. SAST sees a hardcoded secret DAST never will; DAST sees an auth bypass SAST can't. ~4 min.</a:t>
             </a:r>
             <a:endParaRPr lang="en-US" dirty="0"/>
           </a:p>
@@ -1572,7 +1572,7 @@
           <a:p>
             <a:r>
               <a:rPr lang="en-US" dirty="0"/>
-              <a:t/>
+              <a:t>The make-it-concrete slide — point at the exact lines each tool fires on. This is the `vulnerable-repo/app.py` they'll scan in the lab. Ask: "which tool finds the secret? which finds the SQLi? could one tool find both?" ~6 min.</a:t>
             </a:r>
             <a:endParaRPr lang="en-US" dirty="0"/>
           </a:p>
@@ -1660,7 +1660,7 @@
           <a:p>
             <a:r>
               <a:rPr lang="en-US" dirty="0"/>
-              <a:t/>
+              <a:t>Fuzzing is the highest-yield bug finder in industry (most memory CVEs come from it). Explain coverage-guided = the fuzzer "learns" inputs that reach new code. Deep dive + exploit comes in W11. ~5 min.</a:t>
             </a:r>
             <a:endParaRPr lang="en-US" dirty="0"/>
           </a:p>
@@ -1748,7 +1748,7 @@
           <a:p>
             <a:r>
               <a:rPr lang="en-US" dirty="0"/>
-              <a:t/>
+              <a:t>Crucial professional skill: a scanner that cries wolf gets ignored. Show a likely false positive vs a real one. Teach: every finding gets a CWE + a TP/FP call + a one-line justification. ~4 min.</a:t>
             </a:r>
             <a:endParaRPr lang="en-US" dirty="0"/>
           </a:p>
@@ -2410,7 +2410,7 @@
                 <a:ea typeface="Arial" pitchFamily="34" charset="-122"/>
                 <a:cs typeface="Arial" pitchFamily="34" charset="-120"/>
               </a:rPr>
-              <a:t>Triage: not every finding is a bug</a:t>
+              <a:t>Tools you'll meet</a:t>
             </a:r>
             <a:endParaRPr lang="en-US" sz="2600" dirty="0"/>
           </a:p>
@@ -2425,11 +2425,11 @@
         <p:spPr>
           <a:xfrm>
             <a:off x="457200" y="1325880"/>
-            <a:ext cx="8229600" cy="1517904"/>
+            <a:ext cx="8229600" cy="1207008"/>
           </a:xfrm>
           <a:prstGeom prst="roundRect">
             <a:avLst>
-              <a:gd name="adj" fmla="val 4819"/>
+              <a:gd name="adj" fmla="val 6061"/>
             </a:avLst>
           </a:prstGeom>
           <a:solidFill>
@@ -2454,7 +2454,7 @@
         <p:spPr>
           <a:xfrm>
             <a:off x="731520" y="1435608"/>
-            <a:ext cx="7680960" cy="1298448"/>
+            <a:ext cx="7680960" cy="987552"/>
           </a:xfrm>
           <a:prstGeom prst="rect">
             <a:avLst/>
@@ -2482,7 +2482,7 @@
                 <a:ea typeface="Calibri" pitchFamily="34" charset="-122"/>
                 <a:cs typeface="Calibri" pitchFamily="34" charset="-120"/>
               </a:rPr>
-              <a:t>True positive vs false positive</a:t>
+              <a:t>SonarQube — code quality + SAST against the "7 axes" (bugs, duplication, complexity, coverage…)</a:t>
             </a:r>
             <a:endParaRPr lang="en-US" sz="1400" dirty="0"/>
           </a:p>
@@ -2503,7 +2503,7 @@
                 <a:ea typeface="Calibri" pitchFamily="34" charset="-122"/>
                 <a:cs typeface="Calibri" pitchFamily="34" charset="-120"/>
               </a:rPr>
-              <a:t>Map each to a CWE + severity</a:t>
+              <a:t>GitHub Advanced Security (GHAS) — CodeQL + secret scanning + Dependabot, native in the repo</a:t>
             </a:r>
             <a:endParaRPr lang="en-US" sz="1400" dirty="0"/>
           </a:p>
@@ -2524,28 +2524,7 @@
                 <a:ea typeface="Calibri" pitchFamily="34" charset="-122"/>
                 <a:cs typeface="Calibri" pitchFamily="34" charset="-120"/>
               </a:rPr>
-              <a:t>Prioritize by exploitability × impact</a:t>
-            </a:r>
-            <a:endParaRPr lang="en-US" sz="1400" dirty="0"/>
-          </a:p>
-          <a:p>
-            <a:pPr marL="342900" indent="-342900">
-              <a:spcAft>
-                <a:spcPts val="600"/>
-              </a:spcAft>
-              <a:buSzPct val="100000"/>
-              <a:buChar char="•"/>
-            </a:pPr>
-            <a:r>
-              <a:rPr lang="en-US" sz="1400" dirty="0">
-                <a:solidFill>
-                  <a:srgbClr val="E6EDF3"/>
-                </a:solidFill>
-                <a:latin typeface="Calibri" pitchFamily="34" charset="0"/>
-                <a:ea typeface="Calibri" pitchFamily="34" charset="-122"/>
-                <a:cs typeface="Calibri" pitchFamily="34" charset="-120"/>
-              </a:rPr>
-              <a:t>Noise kills trust in tools — triage well</a:t>
+              <a:t>Address technical debt early — cheaper than re-work later</a:t>
             </a:r>
             <a:endParaRPr lang="en-US" sz="1400" dirty="0"/>
           </a:p>
@@ -2774,11 +2753,11 @@
         <p:spPr>
           <a:xfrm>
             <a:off x="457200" y="1325880"/>
-            <a:ext cx="8229600" cy="1207008"/>
+            <a:ext cx="8229600" cy="896112"/>
           </a:xfrm>
           <a:prstGeom prst="roundRect">
             <a:avLst>
-              <a:gd name="adj" fmla="val 6061"/>
+              <a:gd name="adj" fmla="val 8163"/>
             </a:avLst>
           </a:prstGeom>
           <a:solidFill>
@@ -2803,7 +2782,7 @@
         <p:spPr>
           <a:xfrm>
             <a:off x="731520" y="1435608"/>
-            <a:ext cx="7680960" cy="987552"/>
+            <a:ext cx="7680960" cy="676656"/>
           </a:xfrm>
           <a:prstGeom prst="rect">
             <a:avLst/>
@@ -2831,7 +2810,7 @@
                 <a:ea typeface="Calibri" pitchFamily="34" charset="-122"/>
                 <a:cs typeface="Calibri" pitchFamily="34" charset="-120"/>
               </a:rPr>
-              <a:t>Run Semgrep + Gitleaks on a flawed repo</a:t>
+              <a:t>Run Semgrep + Gitleaks on the flawed repo</a:t>
             </a:r>
             <a:endParaRPr lang="en-US" sz="1400" dirty="0"/>
           </a:p>
@@ -2852,31 +2831,10 @@
                 <a:ea typeface="Calibri" pitchFamily="34" charset="-122"/>
                 <a:cs typeface="Calibri" pitchFamily="34" charset="-120"/>
               </a:rPr>
-              <a:t>Score = true positives − misclassified</a:t>
+              <a:t>Score = true positives − misclassified · live scoreboard</a:t>
             </a:r>
             <a:endParaRPr lang="en-US" sz="1400" dirty="0"/>
           </a:p>
-          <a:p>
-            <a:pPr marL="342900" indent="-342900">
-              <a:spcAft>
-                <a:spcPts val="600"/>
-              </a:spcAft>
-              <a:buSzPct val="100000"/>
-              <a:buChar char="•"/>
-            </a:pPr>
-            <a:r>
-              <a:rPr lang="en-US" sz="1400" dirty="0">
-                <a:solidFill>
-                  <a:srgbClr val="E6EDF3"/>
-                </a:solidFill>
-                <a:latin typeface="Calibri" pitchFamily="34" charset="0"/>
-                <a:ea typeface="Calibri" pitchFamily="34" charset="-122"/>
-                <a:cs typeface="Calibri" pitchFamily="34" charset="-120"/>
-              </a:rPr>
-              <a:t>Live scoreboard</a:t>
-            </a:r>
-            <a:endParaRPr lang="en-US" sz="1400" dirty="0"/>
-          </a:p>
         </p:txBody>
       </p:sp>
       <p:sp>
@@ -2887,7 +2845,7 @@
         </p:nvSpPr>
         <p:spPr>
           <a:xfrm>
-            <a:off x="457200" y="2697480"/>
+            <a:off x="457200" y="2386584"/>
             <a:ext cx="8229600" cy="786384"/>
           </a:xfrm>
           <a:prstGeom prst="roundRect">
@@ -2914,7 +2872,7 @@
         </p:nvSpPr>
         <p:spPr>
           <a:xfrm>
-            <a:off x="640080" y="2770632"/>
+            <a:off x="640080" y="2459736"/>
             <a:ext cx="7863840" cy="640080"/>
           </a:xfrm>
           <a:prstGeom prst="rect">
@@ -3513,11 +3471,11 @@
         <p:spPr>
           <a:xfrm>
             <a:off x="457200" y="1325880"/>
-            <a:ext cx="8229600" cy="1207008"/>
+            <a:ext cx="8229600" cy="1517904"/>
           </a:xfrm>
           <a:prstGeom prst="roundRect">
             <a:avLst>
-              <a:gd name="adj" fmla="val 6061"/>
+              <a:gd name="adj" fmla="val 4819"/>
             </a:avLst>
           </a:prstGeom>
           <a:solidFill>
@@ -3542,7 +3500,7 @@
         <p:spPr>
           <a:xfrm>
             <a:off x="731520" y="1435608"/>
-            <a:ext cx="7680960" cy="987552"/>
+            <a:ext cx="7680960" cy="1298448"/>
           </a:xfrm>
           <a:prstGeom prst="rect">
             <a:avLst/>
@@ -3613,6 +3571,27 @@
                 <a:cs typeface="Calibri" pitchFamily="34" charset="-120"/>
               </a:rPr>
               <a:t>1 fuzzing crash with a one-line root cause</a:t>
+            </a:r>
+            <a:endParaRPr lang="en-US" sz="1400" dirty="0"/>
+          </a:p>
+          <a:p>
+            <a:pPr marL="342900" indent="-342900">
+              <a:spcAft>
+                <a:spcPts val="600"/>
+              </a:spcAft>
+              <a:buSzPct val="100000"/>
+              <a:buChar char="•"/>
+            </a:pPr>
+            <a:r>
+              <a:rPr lang="en-US" sz="1400" dirty="0">
+                <a:solidFill>
+                  <a:srgbClr val="E6EDF3"/>
+                </a:solidFill>
+                <a:latin typeface="Calibri" pitchFamily="34" charset="0"/>
+                <a:ea typeface="Calibri" pitchFamily="34" charset="-122"/>
+                <a:cs typeface="Calibri" pitchFamily="34" charset="-120"/>
+              </a:rPr>
+              <a:t>+ Audit the AI and EiPE / Prompt Problem (see worksheet)</a:t>
             </a:r>
             <a:endParaRPr lang="en-US" sz="1400" dirty="0"/>
           </a:p>
@@ -4332,11 +4311,11 @@
         <p:spPr>
           <a:xfrm>
             <a:off x="457200" y="1325880"/>
-            <a:ext cx="8229600" cy="1828800"/>
+            <a:ext cx="8229600" cy="1517904"/>
           </a:xfrm>
           <a:prstGeom prst="roundRect">
             <a:avLst>
-              <a:gd name="adj" fmla="val 4000"/>
+              <a:gd name="adj" fmla="val 4819"/>
             </a:avLst>
           </a:prstGeom>
           <a:solidFill>
@@ -4361,7 +4340,7 @@
         <p:spPr>
           <a:xfrm>
             <a:off x="731520" y="1435608"/>
-            <a:ext cx="7680960" cy="1609344"/>
+            <a:ext cx="7680960" cy="1298448"/>
           </a:xfrm>
           <a:prstGeom prst="rect">
             <a:avLst/>
@@ -4389,7 +4368,7 @@
                 <a:ea typeface="Calibri" pitchFamily="34" charset="-122"/>
                 <a:cs typeface="Calibri" pitchFamily="34" charset="-120"/>
               </a:rPr>
-              <a:t>Security across the SDLC</a:t>
+              <a:t>Security across the SDLC ("shift left")</a:t>
             </a:r>
             <a:endParaRPr lang="en-US" sz="1400" dirty="0"/>
           </a:p>
@@ -4410,28 +4389,7 @@
                 <a:ea typeface="Calibri" pitchFamily="34" charset="-122"/>
                 <a:cs typeface="Calibri" pitchFamily="34" charset="-120"/>
               </a:rPr>
-              <a:t>SAST / DAST / SCA / secret scanning</a:t>
-            </a:r>
-            <a:endParaRPr lang="en-US" sz="1400" dirty="0"/>
-          </a:p>
-          <a:p>
-            <a:pPr marL="342900" indent="-342900">
-              <a:spcAft>
-                <a:spcPts val="600"/>
-              </a:spcAft>
-              <a:buSzPct val="100000"/>
-              <a:buChar char="•"/>
-            </a:pPr>
-            <a:r>
-              <a:rPr lang="en-US" sz="1400" dirty="0">
-                <a:solidFill>
-                  <a:srgbClr val="E6EDF3"/>
-                </a:solidFill>
-                <a:latin typeface="Calibri" pitchFamily="34" charset="0"/>
-                <a:ea typeface="Calibri" pitchFamily="34" charset="-122"/>
-                <a:cs typeface="Calibri" pitchFamily="34" charset="-120"/>
-              </a:rPr>
-              <a:t>Fuzzing — the modern bug-finder</a:t>
+              <a:t>SAST · DAST · SCA · secret scanning · fuzzing</a:t>
             </a:r>
             <a:endParaRPr lang="en-US" sz="1400" dirty="0"/>
           </a:p>
@@ -4473,7 +4431,7 @@
                 <a:ea typeface="Calibri" pitchFamily="34" charset="-122"/>
                 <a:cs typeface="Calibri" pitchFamily="34" charset="-120"/>
               </a:rPr>
-              <a:t>🎮 Game: Bug Triage Race + Fuzzing Race</a:t>
+              <a:t>🏁 Game: Bug Triage Race + a Fuzzing Race</a:t>
             </a:r>
             <a:endParaRPr lang="en-US" sz="1400" dirty="0"/>
           </a:p>
@@ -4759,7 +4717,7 @@
                 <a:ea typeface="Calibri" pitchFamily="34" charset="-122"/>
                 <a:cs typeface="Calibri" pitchFamily="34" charset="-120"/>
               </a:rPr>
-              <a:t>Threat modeling finds design flaws</a:t>
+              <a:t>Threat modeling finds design flaws (before code)</a:t>
             </a:r>
             <a:endParaRPr lang="en-US" sz="1400" dirty="0"/>
           </a:p>
@@ -4780,7 +4738,7 @@
                 <a:ea typeface="Calibri" pitchFamily="34" charset="-122"/>
                 <a:cs typeface="Calibri" pitchFamily="34" charset="-120"/>
               </a:rPr>
-              <a:t>This week: find implementation flaws — automatically</a:t>
+              <a:t>This week: find implementation flaws — automatically, at scale</a:t>
             </a:r>
             <a:endParaRPr lang="en-US" sz="1400" dirty="0"/>
           </a:p>
@@ -4801,7 +4759,7 @@
                 <a:ea typeface="Calibri" pitchFamily="34" charset="-122"/>
                 <a:cs typeface="Calibri" pitchFamily="34" charset="-120"/>
               </a:rPr>
-              <a:t>Shift left: catch bugs before they ship</a:t>
+              <a:t>Same goal: catch it early, cheap to fix</a:t>
             </a:r>
             <a:endParaRPr lang="en-US" sz="1400" dirty="0"/>
           </a:p>
@@ -7105,7 +7063,7 @@
                 <a:ea typeface="Arial" pitchFamily="34" charset="-122"/>
                 <a:cs typeface="Arial" pitchFamily="34" charset="-120"/>
               </a:rPr>
-              <a:t>SCA &amp; secret scanning</a:t>
+              <a:t>Worked example: what each tool catches</a:t>
             </a:r>
             <a:endParaRPr lang="en-US" sz="2600" dirty="0"/>
           </a:p>
@@ -7120,6 +7078,157 @@
         <p:spPr>
           <a:xfrm>
             <a:off x="457200" y="1325880"/>
+            <a:ext cx="8229600" cy="1810512"/>
+          </a:xfrm>
+          <a:prstGeom prst="roundRect">
+            <a:avLst>
+              <a:gd name="adj" fmla="val 3030"/>
+            </a:avLst>
+          </a:prstGeom>
+          <a:solidFill>
+            <a:srgbClr val="0A1020"/>
+          </a:solidFill>
+          <a:ln w="12700">
+            <a:solidFill>
+              <a:srgbClr val="1E2B45"/>
+            </a:solidFill>
+            <a:prstDash val="solid"/>
+          </a:ln>
+        </p:spPr>
+      </p:sp>
+      <p:sp>
+        <p:nvSpPr>
+          <p:cNvPr id="6" name="Text 3"/>
+          <p:cNvSpPr/>
+          <p:nvPr/>
+        </p:nvSpPr>
+        <p:spPr>
+          <a:xfrm>
+            <a:off x="640080" y="1399032"/>
+            <a:ext cx="7863840" cy="1664208"/>
+          </a:xfrm>
+          <a:prstGeom prst="rect">
+            <a:avLst/>
+          </a:prstGeom>
+          <a:noFill/>
+          <a:ln/>
+        </p:spPr>
+        <p:txBody>
+          <a:bodyPr wrap="square" lIns="0" tIns="0" rIns="0" bIns="0" rtlCol="0" anchor="t"/>
+          <a:lstStyle/>
+          <a:p>
+            <a:pPr indent="0" marL="0">
+              <a:buNone/>
+            </a:pPr>
+            <a:r>
+              <a:rPr lang="en-US" sz="1150" dirty="0">
+                <a:solidFill>
+                  <a:srgbClr val="9FE7D6"/>
+                </a:solidFill>
+                <a:latin typeface="Courier New" pitchFamily="34" charset="0"/>
+                <a:ea typeface="Courier New" pitchFamily="34" charset="-122"/>
+                <a:cs typeface="Courier New" pitchFamily="34" charset="-120"/>
+              </a:rPr>
+              <a:t>@app.route("/user")</a:t>
+            </a:r>
+            <a:endParaRPr lang="en-US" sz="1150" dirty="0"/>
+          </a:p>
+          <a:p>
+            <a:pPr indent="0" marL="0">
+              <a:buNone/>
+            </a:pPr>
+            <a:r>
+              <a:rPr lang="en-US" sz="1150" dirty="0">
+                <a:solidFill>
+                  <a:srgbClr val="9FE7D6"/>
+                </a:solidFill>
+                <a:latin typeface="Courier New" pitchFamily="34" charset="0"/>
+                <a:ea typeface="Courier New" pitchFamily="34" charset="-122"/>
+                <a:cs typeface="Courier New" pitchFamily="34" charset="-120"/>
+              </a:rPr>
+              <a:t>def user():</a:t>
+            </a:r>
+            <a:endParaRPr lang="en-US" sz="1150" dirty="0"/>
+          </a:p>
+          <a:p>
+            <a:pPr indent="0" marL="0">
+              <a:buNone/>
+            </a:pPr>
+            <a:r>
+              <a:rPr lang="en-US" sz="1150" dirty="0">
+                <a:solidFill>
+                  <a:srgbClr val="9FE7D6"/>
+                </a:solidFill>
+                <a:latin typeface="Courier New" pitchFamily="34" charset="0"/>
+                <a:ea typeface="Courier New" pitchFamily="34" charset="-122"/>
+                <a:cs typeface="Courier New" pitchFamily="34" charset="-120"/>
+              </a:rPr>
+              <a:t>    name = request.args.get("name")</a:t>
+            </a:r>
+            <a:endParaRPr lang="en-US" sz="1150" dirty="0"/>
+          </a:p>
+          <a:p>
+            <a:pPr indent="0" marL="0">
+              <a:buNone/>
+            </a:pPr>
+            <a:r>
+              <a:rPr lang="en-US" sz="1150" dirty="0">
+                <a:solidFill>
+                  <a:srgbClr val="9FE7D6"/>
+                </a:solidFill>
+                <a:latin typeface="Courier New" pitchFamily="34" charset="0"/>
+                <a:ea typeface="Courier New" pitchFamily="34" charset="-122"/>
+                <a:cs typeface="Courier New" pitchFamily="34" charset="-120"/>
+              </a:rPr>
+              <a:t>    q = "SELECT * FROM users WHERE name='%s'" % name   # SAST → CWE-89</a:t>
+            </a:r>
+            <a:endParaRPr lang="en-US" sz="1150" dirty="0"/>
+          </a:p>
+          <a:p>
+            <a:pPr indent="0" marL="0">
+              <a:buNone/>
+            </a:pPr>
+            <a:r>
+              <a:rPr lang="en-US" sz="1150" dirty="0">
+                <a:solidFill>
+                  <a:srgbClr val="9FE7D6"/>
+                </a:solidFill>
+                <a:latin typeface="Courier New" pitchFamily="34" charset="0"/>
+                <a:ea typeface="Courier New" pitchFamily="34" charset="-122"/>
+                <a:cs typeface="Courier New" pitchFamily="34" charset="-120"/>
+              </a:rPr>
+              <a:t>    return db.execute(q).fetchall()</a:t>
+            </a:r>
+            <a:endParaRPr lang="en-US" sz="1150" dirty="0"/>
+          </a:p>
+          <a:p>
+            <a:pPr indent="0" marL="0">
+              <a:buNone/>
+            </a:pPr>
+            <a:r>
+              <a:rPr lang="en-US" sz="1150" dirty="0">
+                <a:solidFill>
+                  <a:srgbClr val="9FE7D6"/>
+                </a:solidFill>
+                <a:latin typeface="Courier New" pitchFamily="34" charset="0"/>
+                <a:ea typeface="Courier New" pitchFamily="34" charset="-122"/>
+                <a:cs typeface="Courier New" pitchFamily="34" charset="-120"/>
+              </a:rPr>
+              <a:t>AWS_SECRET = "wJalr...EXAMPLEKEY"                       # Gitleaks → CWE-798</a:t>
+            </a:r>
+            <a:endParaRPr lang="en-US" sz="1150" dirty="0"/>
+          </a:p>
+        </p:txBody>
+      </p:sp>
+      <p:sp>
+        <p:nvSpPr>
+          <p:cNvPr id="7" name="Shape 4"/>
+          <p:cNvSpPr/>
+          <p:nvPr/>
+        </p:nvSpPr>
+        <p:spPr>
+          <a:xfrm>
+            <a:off x="457200" y="3300984"/>
             <a:ext cx="8229600" cy="1207008"/>
           </a:xfrm>
           <a:prstGeom prst="roundRect">
@@ -7142,13 +7251,13 @@
       </p:sp>
       <p:sp>
         <p:nvSpPr>
-          <p:cNvPr id="6" name="Text 3"/>
-          <p:cNvSpPr/>
-          <p:nvPr/>
-        </p:nvSpPr>
-        <p:spPr>
-          <a:xfrm>
-            <a:off x="731520" y="1435608"/>
+          <p:cNvPr id="8" name="Text 5"/>
+          <p:cNvSpPr/>
+          <p:nvPr/>
+        </p:nvSpPr>
+        <p:spPr>
+          <a:xfrm>
+            <a:off x="731520" y="3410712"/>
             <a:ext cx="7680960" cy="987552"/>
           </a:xfrm>
           <a:prstGeom prst="rect">
@@ -7177,7 +7286,7 @@
                 <a:ea typeface="Calibri" pitchFamily="34" charset="-122"/>
                 <a:cs typeface="Calibri" pitchFamily="34" charset="-120"/>
               </a:rPr>
-              <a:t>SCA — your dependencies' known CVEs (deep dive in Wk 12)</a:t>
+              <a:t>Semgrep (SAST): flags the string-built SQL query (CWE-89)</a:t>
             </a:r>
             <a:endParaRPr lang="en-US" sz="1400" dirty="0"/>
           </a:p>
@@ -7198,7 +7307,7 @@
                 <a:ea typeface="Calibri" pitchFamily="34" charset="-122"/>
                 <a:cs typeface="Calibri" pitchFamily="34" charset="-120"/>
               </a:rPr>
-              <a:t>Secret scanning — API keys/passwords committed to git history</a:t>
+              <a:t>Gitleaks (secret scan): flags the hardcoded AWS key (CWE-798)</a:t>
             </a:r>
             <a:endParaRPr lang="en-US" sz="1400" dirty="0"/>
           </a:p>
@@ -7219,7 +7328,7 @@
                 <a:ea typeface="Calibri" pitchFamily="34" charset="-122"/>
                 <a:cs typeface="Calibri" pitchFamily="34" charset="-120"/>
               </a:rPr>
-              <a:t>Both run automatically in CI</a:t>
+              <a:t>DAST/fuzzer: would catch a crash/SQLi by hitting /user, not reading it</a:t>
             </a:r>
             <a:endParaRPr lang="en-US" sz="1400" dirty="0"/>
           </a:p>
@@ -7227,7 +7336,7 @@
       </p:sp>
       <p:sp>
         <p:nvSpPr>
-          <p:cNvPr id="7" name="Text 4"/>
+          <p:cNvPr id="9" name="Text 6"/>
           <p:cNvSpPr/>
           <p:nvPr/>
         </p:nvSpPr>
@@ -7266,7 +7375,7 @@
       </p:sp>
       <p:sp>
         <p:nvSpPr>
-          <p:cNvPr id="8" name="Shape 5"/>
+          <p:cNvPr id="10" name="Shape 7"/>
           <p:cNvSpPr/>
           <p:nvPr/>
         </p:nvSpPr>
@@ -7295,7 +7404,7 @@
       </p:sp>
       <p:pic>
         <p:nvPicPr>
-          <p:cNvPr id="9" name="Image 1" descr="/Users/pop7/Library/CloudStorage/OneDrive-MonsterConnectCo.,Ltd/Lecture/KOSEN69 - software-security/slides/pptx/assets/logo-small.png">    </p:cNvPr>
+          <p:cNvPr id="11" name="Image 1" descr="/Users/pop7/Library/CloudStorage/OneDrive-MonsterConnectCo.,Ltd/Lecture/KOSEN69 - software-security/slides/pptx/assets/logo-small.png">    </p:cNvPr>
           <p:cNvPicPr>
             <a:picLocks noChangeAspect="1"/>
           </p:cNvPicPr>
@@ -7433,7 +7542,7 @@
                 <a:ea typeface="Arial" pitchFamily="34" charset="-122"/>
                 <a:cs typeface="Arial" pitchFamily="34" charset="-120"/>
               </a:rPr>
-              <a:t>Tools you'll meet</a:t>
+              <a:t>Fuzzing — how real CVEs are found</a:t>
             </a:r>
             <a:endParaRPr lang="en-US" sz="2600" dirty="0"/>
           </a:p>
@@ -7505,7 +7614,7 @@
                 <a:ea typeface="Calibri" pitchFamily="34" charset="-122"/>
                 <a:cs typeface="Calibri" pitchFamily="34" charset="-120"/>
               </a:rPr>
-              <a:t>SonarQube — code quality + SAST against the "7 axes" (bugs, duplication, complexity, coverage…)</a:t>
+              <a:t>Feed random/mutated inputs, watch for crashes</a:t>
             </a:r>
             <a:endParaRPr lang="en-US" sz="1400" dirty="0"/>
           </a:p>
@@ -7526,7 +7635,7 @@
                 <a:ea typeface="Calibri" pitchFamily="34" charset="-122"/>
                 <a:cs typeface="Calibri" pitchFamily="34" charset="-120"/>
               </a:rPr>
-              <a:t>GitHub Advanced Security (GHAS) — CodeQL + secret scanning + Dependabot, native in the repo</a:t>
+              <a:t>Coverage-guided (libFuzzer/AFL++) explores new code paths</a:t>
             </a:r>
             <a:endParaRPr lang="en-US" sz="1400" dirty="0"/>
           </a:p>
@@ -7547,7 +7656,7 @@
                 <a:ea typeface="Calibri" pitchFamily="34" charset="-122"/>
                 <a:cs typeface="Calibri" pitchFamily="34" charset="-120"/>
               </a:rPr>
-              <a:t>Address technical debt early — cheaper than re-work later</a:t>
+              <a:t>Pair with sanitizers (ASan) to pinpoint the bug</a:t>
             </a:r>
             <a:endParaRPr lang="en-US" sz="1400" dirty="0"/>
           </a:p>
@@ -7555,7 +7664,73 @@
       </p:sp>
       <p:sp>
         <p:nvSpPr>
-          <p:cNvPr id="7" name="Text 4"/>
+          <p:cNvPr id="7" name="Shape 4"/>
+          <p:cNvSpPr/>
+          <p:nvPr/>
+        </p:nvSpPr>
+        <p:spPr>
+          <a:xfrm>
+            <a:off x="457200" y="2697480"/>
+            <a:ext cx="8229600" cy="530352"/>
+          </a:xfrm>
+          <a:prstGeom prst="roundRect">
+            <a:avLst>
+              <a:gd name="adj" fmla="val 10345"/>
+            </a:avLst>
+          </a:prstGeom>
+          <a:solidFill>
+            <a:srgbClr val="0A1020"/>
+          </a:solidFill>
+          <a:ln w="12700">
+            <a:solidFill>
+              <a:srgbClr val="1E2B45"/>
+            </a:solidFill>
+            <a:prstDash val="solid"/>
+          </a:ln>
+        </p:spPr>
+      </p:sp>
+      <p:sp>
+        <p:nvSpPr>
+          <p:cNvPr id="8" name="Text 5"/>
+          <p:cNvSpPr/>
+          <p:nvPr/>
+        </p:nvSpPr>
+        <p:spPr>
+          <a:xfrm>
+            <a:off x="640080" y="2770632"/>
+            <a:ext cx="7863840" cy="384048"/>
+          </a:xfrm>
+          <a:prstGeom prst="rect">
+            <a:avLst/>
+          </a:prstGeom>
+          <a:noFill/>
+          <a:ln/>
+        </p:spPr>
+        <p:txBody>
+          <a:bodyPr wrap="square" lIns="0" tIns="0" rIns="0" bIns="0" rtlCol="0" anchor="t"/>
+          <a:lstStyle/>
+          <a:p>
+            <a:pPr indent="0" marL="0">
+              <a:buNone/>
+            </a:pPr>
+            <a:r>
+              <a:rPr lang="en-US" sz="1150" dirty="0">
+                <a:solidFill>
+                  <a:srgbClr val="9FE7D6"/>
+                </a:solidFill>
+                <a:latin typeface="Courier New" pitchFamily="34" charset="0"/>
+                <a:ea typeface="Courier New" pitchFamily="34" charset="-122"/>
+                <a:cs typeface="Courier New" pitchFamily="34" charset="-120"/>
+              </a:rPr>
+              <a:t>clang -fsanitize=address,fuzzer harness.c -o fuzz &amp;&amp; ./fuzz</a:t>
+            </a:r>
+            <a:endParaRPr lang="en-US" sz="1150" dirty="0"/>
+          </a:p>
+        </p:txBody>
+      </p:sp>
+      <p:sp>
+        <p:nvSpPr>
+          <p:cNvPr id="9" name="Text 6"/>
           <p:cNvSpPr/>
           <p:nvPr/>
         </p:nvSpPr>
@@ -7594,7 +7769,7 @@
       </p:sp>
       <p:sp>
         <p:nvSpPr>
-          <p:cNvPr id="8" name="Shape 5"/>
+          <p:cNvPr id="10" name="Shape 7"/>
           <p:cNvSpPr/>
           <p:nvPr/>
         </p:nvSpPr>
@@ -7623,7 +7798,7 @@
       </p:sp>
       <p:pic>
         <p:nvPicPr>
-          <p:cNvPr id="9" name="Image 1" descr="/Users/pop7/Library/CloudStorage/OneDrive-MonsterConnectCo.,Ltd/Lecture/KOSEN69 - software-security/slides/pptx/assets/logo-small.png">    </p:cNvPr>
+          <p:cNvPr id="11" name="Image 1" descr="/Users/pop7/Library/CloudStorage/OneDrive-MonsterConnectCo.,Ltd/Lecture/KOSEN69 - software-security/slides/pptx/assets/logo-small.png">    </p:cNvPr>
           <p:cNvPicPr>
             <a:picLocks noChangeAspect="1"/>
           </p:cNvPicPr>
@@ -7761,7 +7936,7 @@
                 <a:ea typeface="Arial" pitchFamily="34" charset="-122"/>
                 <a:cs typeface="Arial" pitchFamily="34" charset="-120"/>
               </a:rPr>
-              <a:t>Fuzzing — how real CVEs are found</a:t>
+              <a:t>Triage: not every finding is a bug</a:t>
             </a:r>
             <a:endParaRPr lang="en-US" sz="2600" dirty="0"/>
           </a:p>
@@ -7776,11 +7951,11 @@
         <p:spPr>
           <a:xfrm>
             <a:off x="457200" y="1325880"/>
-            <a:ext cx="8229600" cy="1207008"/>
+            <a:ext cx="8229600" cy="1517904"/>
           </a:xfrm>
           <a:prstGeom prst="roundRect">
             <a:avLst>
-              <a:gd name="adj" fmla="val 6061"/>
+              <a:gd name="adj" fmla="val 4819"/>
             </a:avLst>
           </a:prstGeom>
           <a:solidFill>
@@ -7805,7 +7980,7 @@
         <p:spPr>
           <a:xfrm>
             <a:off x="731520" y="1435608"/>
-            <a:ext cx="7680960" cy="987552"/>
+            <a:ext cx="7680960" cy="1298448"/>
           </a:xfrm>
           <a:prstGeom prst="rect">
             <a:avLst/>
@@ -7833,7 +8008,7 @@
                 <a:ea typeface="Calibri" pitchFamily="34" charset="-122"/>
                 <a:cs typeface="Calibri" pitchFamily="34" charset="-120"/>
               </a:rPr>
-              <a:t>Feed random/mutated inputs, watch for crashes</a:t>
+              <a:t>True positive vs false positive</a:t>
             </a:r>
             <a:endParaRPr lang="en-US" sz="1400" dirty="0"/>
           </a:p>
@@ -7854,7 +8029,7 @@
                 <a:ea typeface="Calibri" pitchFamily="34" charset="-122"/>
                 <a:cs typeface="Calibri" pitchFamily="34" charset="-120"/>
               </a:rPr>
-              <a:t>Coverage-guided (libFuzzer/AFL++) explores new paths</a:t>
+              <a:t>Map each to a CWE + severity</a:t>
             </a:r>
             <a:endParaRPr lang="en-US" sz="1400" dirty="0"/>
           </a:p>
@@ -7875,81 +8050,36 @@
                 <a:ea typeface="Calibri" pitchFamily="34" charset="-122"/>
                 <a:cs typeface="Calibri" pitchFamily="34" charset="-120"/>
               </a:rPr>
-              <a:t>Pair with sanitizers (ASan) to pinpoint the bug</a:t>
+              <a:t>Prioritize by exploitability × impact</a:t>
             </a:r>
             <a:endParaRPr lang="en-US" sz="1400" dirty="0"/>
           </a:p>
+          <a:p>
+            <a:pPr marL="342900" indent="-342900">
+              <a:spcAft>
+                <a:spcPts val="600"/>
+              </a:spcAft>
+              <a:buSzPct val="100000"/>
+              <a:buChar char="•"/>
+            </a:pPr>
+            <a:r>
+              <a:rPr lang="en-US" sz="1400" dirty="0">
+                <a:solidFill>
+                  <a:srgbClr val="E6EDF3"/>
+                </a:solidFill>
+                <a:latin typeface="Calibri" pitchFamily="34" charset="0"/>
+                <a:ea typeface="Calibri" pitchFamily="34" charset="-122"/>
+                <a:cs typeface="Calibri" pitchFamily="34" charset="-120"/>
+              </a:rPr>
+              <a:t>Noise kills trust in tools — triage well</a:t>
+            </a:r>
+            <a:endParaRPr lang="en-US" sz="1400" dirty="0"/>
+          </a:p>
         </p:txBody>
       </p:sp>
       <p:sp>
         <p:nvSpPr>
-          <p:cNvPr id="7" name="Shape 4"/>
-          <p:cNvSpPr/>
-          <p:nvPr/>
-        </p:nvSpPr>
-        <p:spPr>
-          <a:xfrm>
-            <a:off x="457200" y="2697480"/>
-            <a:ext cx="8229600" cy="530352"/>
-          </a:xfrm>
-          <a:prstGeom prst="roundRect">
-            <a:avLst>
-              <a:gd name="adj" fmla="val 10345"/>
-            </a:avLst>
-          </a:prstGeom>
-          <a:solidFill>
-            <a:srgbClr val="0A1020"/>
-          </a:solidFill>
-          <a:ln w="12700">
-            <a:solidFill>
-              <a:srgbClr val="1E2B45"/>
-            </a:solidFill>
-            <a:prstDash val="solid"/>
-          </a:ln>
-        </p:spPr>
-      </p:sp>
-      <p:sp>
-        <p:nvSpPr>
-          <p:cNvPr id="8" name="Text 5"/>
-          <p:cNvSpPr/>
-          <p:nvPr/>
-        </p:nvSpPr>
-        <p:spPr>
-          <a:xfrm>
-            <a:off x="640080" y="2770632"/>
-            <a:ext cx="7863840" cy="384048"/>
-          </a:xfrm>
-          <a:prstGeom prst="rect">
-            <a:avLst/>
-          </a:prstGeom>
-          <a:noFill/>
-          <a:ln/>
-        </p:spPr>
-        <p:txBody>
-          <a:bodyPr wrap="square" lIns="0" tIns="0" rIns="0" bIns="0" rtlCol="0" anchor="t"/>
-          <a:lstStyle/>
-          <a:p>
-            <a:pPr indent="0" marL="0">
-              <a:buNone/>
-            </a:pPr>
-            <a:r>
-              <a:rPr lang="en-US" sz="1150" dirty="0">
-                <a:solidFill>
-                  <a:srgbClr val="9FE7D6"/>
-                </a:solidFill>
-                <a:latin typeface="Courier New" pitchFamily="34" charset="0"/>
-                <a:ea typeface="Courier New" pitchFamily="34" charset="-122"/>
-                <a:cs typeface="Courier New" pitchFamily="34" charset="-120"/>
-              </a:rPr>
-              <a:t>clang -fsanitize=address,fuzzer harness.c -o fuzz &amp;&amp; ./fuzz</a:t>
-            </a:r>
-            <a:endParaRPr lang="en-US" sz="1150" dirty="0"/>
-          </a:p>
-        </p:txBody>
-      </p:sp>
-      <p:sp>
-        <p:nvSpPr>
-          <p:cNvPr id="9" name="Text 6"/>
+          <p:cNvPr id="7" name="Text 4"/>
           <p:cNvSpPr/>
           <p:nvPr/>
         </p:nvSpPr>
@@ -7988,7 +8118,7 @@
       </p:sp>
       <p:sp>
         <p:nvSpPr>
-          <p:cNvPr id="10" name="Shape 7"/>
+          <p:cNvPr id="8" name="Shape 5"/>
           <p:cNvSpPr/>
           <p:nvPr/>
         </p:nvSpPr>
@@ -8017,7 +8147,7 @@
       </p:sp>
       <p:pic>
         <p:nvPicPr>
-          <p:cNvPr id="11" name="Image 1" descr="/Users/pop7/Library/CloudStorage/OneDrive-MonsterConnectCo.,Ltd/Lecture/KOSEN69 - software-security/slides/pptx/assets/logo-small.png">    </p:cNvPr>
+          <p:cNvPr id="9" name="Image 1" descr="/Users/pop7/Library/CloudStorage/OneDrive-MonsterConnectCo.,Ltd/Lecture/KOSEN69 - software-security/slides/pptx/assets/logo-small.png">    </p:cNvPr>
           <p:cNvPicPr>
             <a:picLocks noChangeAspect="1"/>
           </p:cNvPicPr>

</xml_diff>